<commit_message>
Lessons sd-07-013, deck sd-07-015: fix section count and slide 3 bank count
Co-Authored-By: Claude Sonnet 5.5 <noreply@anthropic.com>
Claude-Session: https://claude.ai/code/session_01C1SaH6cnt22FTK5D8YYaoH
</commit_message>
<xml_diff>
--- a/system-design-101/vi/lessons/sd-07-015/slides/sd-07-015.pptx
+++ b/system-design-101/vi/lessons/sd-07-015/slides/sd-07-015.pptx
@@ -5567,10 +5567,10 @@
                 <a:ea typeface="Bricolage Grotesque ExtraBold" pitchFamily="34" charset="-122"/>
                 <a:cs typeface="Bricolage Grotesque ExtraBold" pitchFamily="34" charset="-120"/>
               </a:rPr>
-              <a:t>Hai</a:t>
-            </a:r>
-            <a:r>
-              <a:rPr lang="en-US" sz="6900" dirty="0" spc="-95" kern="0">
+              <a:t>Năm</a:t>
+            </a:r>
+            <a:r>
+              <a:rPr lang="en-US" sz="6900" dirty="0" spc="-9" kern="0">
                 <a:solidFill>
                   <a:srgbClr val="F3EEE3"/>
                 </a:solidFill>
@@ -5578,10 +5578,10 @@
                 <a:ea typeface="Bricolage Grotesque ExtraBold" pitchFamily="34" charset="-122"/>
                 <a:cs typeface="Bricolage Grotesque ExtraBold" pitchFamily="34" charset="-120"/>
               </a:rPr>
-              <a:t> bước</a:t>
-            </a:r>
-            <a:r>
-              <a:rPr lang="en-US" sz="6900" dirty="0" spc="4" kern="0">
+              <a:t> ngân</a:t>
+            </a:r>
+            <a:r>
+              <a:rPr lang="en-US" sz="6900" dirty="0" spc="22" kern="0">
                 <a:solidFill>
                   <a:srgbClr val="F3EEE3"/>
                 </a:solidFill>
@@ -5589,10 +5589,10 @@
                 <a:ea typeface="Bricolage Grotesque ExtraBold" pitchFamily="34" charset="-122"/>
                 <a:cs typeface="Bricolage Grotesque ExtraBold" pitchFamily="34" charset="-120"/>
               </a:rPr>
-              <a:t> đầu,</a:t>
-            </a:r>
-            <a:r>
-              <a:rPr lang="en-US" sz="6900" dirty="0" spc="1" kern="0">
+              <a:t> hàng,</a:t>
+            </a:r>
+            <a:r>
+              <a:rPr lang="en-US" sz="6900" dirty="0" spc="2" kern="0">
                 <a:solidFill>
                   <a:srgbClr val="F3EEE3"/>
                 </a:solidFill>
@@ -5600,10 +5600,10 @@
                 <a:ea typeface="Bricolage Grotesque ExtraBold" pitchFamily="34" charset="-122"/>
                 <a:cs typeface="Bricolage Grotesque ExtraBold" pitchFamily="34" charset="-120"/>
               </a:rPr>
-              <a:t> bốn</a:t>
-            </a:r>
-            <a:r>
-              <a:rPr lang="en-US" sz="6900" dirty="0" spc="-9" kern="0">
+              <a:t> hai</a:t>
+            </a:r>
+            <a:r>
+              <a:rPr lang="en-US" sz="6900" dirty="0" spc="-95" kern="0">
                 <a:solidFill>
                   <a:srgbClr val="F3EEE3"/>
                 </a:solidFill>
@@ -5611,10 +5611,10 @@
                 <a:ea typeface="Bricolage Grotesque ExtraBold" pitchFamily="34" charset="-122"/>
                 <a:cs typeface="Bricolage Grotesque ExtraBold" pitchFamily="34" charset="-120"/>
               </a:rPr>
-              <a:t> ngân</a:t>
-            </a:r>
-            <a:r>
-              <a:rPr lang="en-US" sz="6900" dirty="0" spc="2" kern="0">
+              <a:t> bước</a:t>
+            </a:r>
+            <a:r>
+              <a:rPr lang="en-US" sz="6900" dirty="0" spc="10" kern="0">
                 <a:solidFill>
                   <a:srgbClr val="F3EEE3"/>
                 </a:solidFill>
@@ -5622,7 +5622,7 @@
                 <a:ea typeface="Bricolage Grotesque ExtraBold" pitchFamily="34" charset="-122"/>
                 <a:cs typeface="Bricolage Grotesque ExtraBold" pitchFamily="34" charset="-120"/>
               </a:rPr>
-              <a:t> hàng</a:t>
+              <a:t> đầu</a:t>
             </a:r>
             <a:endParaRPr lang="en-US" sz="6900" dirty="0"/>
           </a:p>

</xml_diff>